<commit_message>
coding in agentic ai
</commit_message>
<xml_diff>
--- a/Tomato_Presentation.pptx
+++ b/Tomato_Presentation.pptx
@@ -5,11 +5,11 @@
     <p:sldMasterId id="2147483648" r:id="rId1"/>
   </p:sldMasterIdLst>
   <p:sldIdLst>
-    <p:sldId id="256" r:id="rId7"/>
-    <p:sldId id="257" r:id="rId8"/>
-    <p:sldId id="258" r:id="rId9"/>
-    <p:sldId id="260" r:id="rId11"/>
-    <p:sldId id="261" r:id="rId12"/>
+    <p:sldId id="256" r:id="rId2"/>
+    <p:sldId id="257" r:id="rId3"/>
+    <p:sldId id="258" r:id="rId4"/>
+    <p:sldId id="260" r:id="rId5"/>
+    <p:sldId id="261" r:id="rId6"/>
   </p:sldIdLst>
   <p:sldSz cx="9144000" cy="6858000" type="screen4x3"/>
   <p:notesSz cx="6858000" cy="9144000"/>
@@ -108,6 +108,22 @@
       </a:defRPr>
     </a:lvl9pPr>
   </p:defaultTextStyle>
+  <p:extLst>
+    <p:ext uri="{EFAFB233-063F-42B5-8137-9DF3F51BA10A}">
+      <p15:sldGuideLst xmlns:p15="http://schemas.microsoft.com/office/powerpoint/2012/main">
+        <p15:guide id="1" orient="horz" pos="2160">
+          <p15:clr>
+            <a:srgbClr val="A4A3A4"/>
+          </p15:clr>
+        </p15:guide>
+        <p15:guide id="2" pos="2880">
+          <p15:clr>
+            <a:srgbClr val="A4A3A4"/>
+          </p15:clr>
+        </p15:guide>
+      </p15:sldGuideLst>
+    </p:ext>
+  </p:extLst>
 </p:presentation>
 </file>
 
@@ -149,10 +165,9 @@
           <a:lstStyle/>
           <a:p>
             <a:r>
-              <a:rPr lang="en-US" smtClean="0"/>
+              <a:rPr lang="en-US"/>
               <a:t>Click to edit Master title style</a:t>
             </a:r>
-            <a:endParaRPr lang="en-US"/>
           </a:p>
         </p:txBody>
       </p:sp>
@@ -268,10 +283,9 @@
           </a:lstStyle>
           <a:p>
             <a:r>
-              <a:rPr lang="en-US" smtClean="0"/>
+              <a:rPr lang="en-US"/>
               <a:t>Click to edit Master subtitle style</a:t>
             </a:r>
-            <a:endParaRPr lang="en-US"/>
           </a:p>
         </p:txBody>
       </p:sp>
@@ -292,7 +306,7 @@
           <a:p>
             <a:fld id="{5BCAD085-E8A6-8845-BD4E-CB4CCA059FC4}" type="datetimeFigureOut">
               <a:rPr lang="en-US" smtClean="0"/>
-              <a:t>1/27/13</a:t>
+              <a:t>4/6/2026</a:t>
             </a:fld>
             <a:endParaRPr lang="en-US"/>
           </a:p>
@@ -386,10 +400,9 @@
           <a:lstStyle/>
           <a:p>
             <a:r>
-              <a:rPr lang="en-US" smtClean="0"/>
+              <a:rPr lang="en-US"/>
               <a:t>Click to edit Master title style</a:t>
             </a:r>
-            <a:endParaRPr lang="en-US"/>
           </a:p>
         </p:txBody>
       </p:sp>
@@ -410,38 +423,37 @@
           <a:p>
             <a:pPr lvl="0"/>
             <a:r>
-              <a:rPr lang="en-US" smtClean="0"/>
+              <a:rPr lang="en-US"/>
               <a:t>Click to edit Master text styles</a:t>
             </a:r>
           </a:p>
           <a:p>
             <a:pPr lvl="1"/>
             <a:r>
-              <a:rPr lang="en-US" smtClean="0"/>
+              <a:rPr lang="en-US"/>
               <a:t>Second level</a:t>
             </a:r>
           </a:p>
           <a:p>
             <a:pPr lvl="2"/>
             <a:r>
-              <a:rPr lang="en-US" smtClean="0"/>
+              <a:rPr lang="en-US"/>
               <a:t>Third level</a:t>
             </a:r>
           </a:p>
           <a:p>
             <a:pPr lvl="3"/>
             <a:r>
-              <a:rPr lang="en-US" smtClean="0"/>
+              <a:rPr lang="en-US"/>
               <a:t>Fourth level</a:t>
             </a:r>
           </a:p>
           <a:p>
             <a:pPr lvl="4"/>
             <a:r>
-              <a:rPr lang="en-US" smtClean="0"/>
+              <a:rPr lang="en-US"/>
               <a:t>Fifth level</a:t>
             </a:r>
-            <a:endParaRPr lang="en-US"/>
           </a:p>
         </p:txBody>
       </p:sp>
@@ -462,7 +474,7 @@
           <a:p>
             <a:fld id="{5BCAD085-E8A6-8845-BD4E-CB4CCA059FC4}" type="datetimeFigureOut">
               <a:rPr lang="en-US" smtClean="0"/>
-              <a:t>1/27/13</a:t>
+              <a:t>4/6/2026</a:t>
             </a:fld>
             <a:endParaRPr lang="en-US"/>
           </a:p>
@@ -561,10 +573,9 @@
           <a:lstStyle/>
           <a:p>
             <a:r>
-              <a:rPr lang="en-US" smtClean="0"/>
+              <a:rPr lang="en-US"/>
               <a:t>Click to edit Master title style</a:t>
             </a:r>
-            <a:endParaRPr lang="en-US"/>
           </a:p>
         </p:txBody>
       </p:sp>
@@ -590,38 +601,37 @@
           <a:p>
             <a:pPr lvl="0"/>
             <a:r>
-              <a:rPr lang="en-US" smtClean="0"/>
+              <a:rPr lang="en-US"/>
               <a:t>Click to edit Master text styles</a:t>
             </a:r>
           </a:p>
           <a:p>
             <a:pPr lvl="1"/>
             <a:r>
-              <a:rPr lang="en-US" smtClean="0"/>
+              <a:rPr lang="en-US"/>
               <a:t>Second level</a:t>
             </a:r>
           </a:p>
           <a:p>
             <a:pPr lvl="2"/>
             <a:r>
-              <a:rPr lang="en-US" smtClean="0"/>
+              <a:rPr lang="en-US"/>
               <a:t>Third level</a:t>
             </a:r>
           </a:p>
           <a:p>
             <a:pPr lvl="3"/>
             <a:r>
-              <a:rPr lang="en-US" smtClean="0"/>
+              <a:rPr lang="en-US"/>
               <a:t>Fourth level</a:t>
             </a:r>
           </a:p>
           <a:p>
             <a:pPr lvl="4"/>
             <a:r>
-              <a:rPr lang="en-US" smtClean="0"/>
+              <a:rPr lang="en-US"/>
               <a:t>Fifth level</a:t>
             </a:r>
-            <a:endParaRPr lang="en-US"/>
           </a:p>
         </p:txBody>
       </p:sp>
@@ -642,7 +652,7 @@
           <a:p>
             <a:fld id="{5BCAD085-E8A6-8845-BD4E-CB4CCA059FC4}" type="datetimeFigureOut">
               <a:rPr lang="en-US" smtClean="0"/>
-              <a:t>1/27/13</a:t>
+              <a:t>4/6/2026</a:t>
             </a:fld>
             <a:endParaRPr lang="en-US"/>
           </a:p>
@@ -736,10 +746,9 @@
           <a:lstStyle/>
           <a:p>
             <a:r>
-              <a:rPr lang="en-US" smtClean="0"/>
+              <a:rPr lang="en-US"/>
               <a:t>Click to edit Master title style</a:t>
             </a:r>
-            <a:endParaRPr lang="en-US"/>
           </a:p>
         </p:txBody>
       </p:sp>
@@ -760,38 +769,37 @@
           <a:p>
             <a:pPr lvl="0"/>
             <a:r>
-              <a:rPr lang="en-US" smtClean="0"/>
+              <a:rPr lang="en-US"/>
               <a:t>Click to edit Master text styles</a:t>
             </a:r>
           </a:p>
           <a:p>
             <a:pPr lvl="1"/>
             <a:r>
-              <a:rPr lang="en-US" smtClean="0"/>
+              <a:rPr lang="en-US"/>
               <a:t>Second level</a:t>
             </a:r>
           </a:p>
           <a:p>
             <a:pPr lvl="2"/>
             <a:r>
-              <a:rPr lang="en-US" smtClean="0"/>
+              <a:rPr lang="en-US"/>
               <a:t>Third level</a:t>
             </a:r>
           </a:p>
           <a:p>
             <a:pPr lvl="3"/>
             <a:r>
-              <a:rPr lang="en-US" smtClean="0"/>
+              <a:rPr lang="en-US"/>
               <a:t>Fourth level</a:t>
             </a:r>
           </a:p>
           <a:p>
             <a:pPr lvl="4"/>
             <a:r>
-              <a:rPr lang="en-US" smtClean="0"/>
+              <a:rPr lang="en-US"/>
               <a:t>Fifth level</a:t>
             </a:r>
-            <a:endParaRPr lang="en-US"/>
           </a:p>
         </p:txBody>
       </p:sp>
@@ -812,7 +820,7 @@
           <a:p>
             <a:fld id="{5BCAD085-E8A6-8845-BD4E-CB4CCA059FC4}" type="datetimeFigureOut">
               <a:rPr lang="en-US" smtClean="0"/>
-              <a:t>1/27/13</a:t>
+              <a:t>4/6/2026</a:t>
             </a:fld>
             <a:endParaRPr lang="en-US"/>
           </a:p>
@@ -915,10 +923,9 @@
           </a:lstStyle>
           <a:p>
             <a:r>
-              <a:rPr lang="en-US" smtClean="0"/>
+              <a:rPr lang="en-US"/>
               <a:t>Click to edit Master title style</a:t>
             </a:r>
-            <a:endParaRPr lang="en-US"/>
           </a:p>
         </p:txBody>
       </p:sp>
@@ -1035,7 +1042,7 @@
           <a:p>
             <a:pPr lvl="0"/>
             <a:r>
-              <a:rPr lang="en-US" smtClean="0"/>
+              <a:rPr lang="en-US"/>
               <a:t>Click to edit Master text styles</a:t>
             </a:r>
           </a:p>
@@ -1058,7 +1065,7 @@
           <a:p>
             <a:fld id="{5BCAD085-E8A6-8845-BD4E-CB4CCA059FC4}" type="datetimeFigureOut">
               <a:rPr lang="en-US" smtClean="0"/>
-              <a:t>1/27/13</a:t>
+              <a:t>4/6/2026</a:t>
             </a:fld>
             <a:endParaRPr lang="en-US"/>
           </a:p>
@@ -1152,10 +1159,9 @@
           <a:lstStyle/>
           <a:p>
             <a:r>
-              <a:rPr lang="en-US" smtClean="0"/>
+              <a:rPr lang="en-US"/>
               <a:t>Click to edit Master title style</a:t>
             </a:r>
-            <a:endParaRPr lang="en-US"/>
           </a:p>
         </p:txBody>
       </p:sp>
@@ -1209,38 +1215,37 @@
           <a:p>
             <a:pPr lvl="0"/>
             <a:r>
-              <a:rPr lang="en-US" smtClean="0"/>
+              <a:rPr lang="en-US"/>
               <a:t>Click to edit Master text styles</a:t>
             </a:r>
           </a:p>
           <a:p>
             <a:pPr lvl="1"/>
             <a:r>
-              <a:rPr lang="en-US" smtClean="0"/>
+              <a:rPr lang="en-US"/>
               <a:t>Second level</a:t>
             </a:r>
           </a:p>
           <a:p>
             <a:pPr lvl="2"/>
             <a:r>
-              <a:rPr lang="en-US" smtClean="0"/>
+              <a:rPr lang="en-US"/>
               <a:t>Third level</a:t>
             </a:r>
           </a:p>
           <a:p>
             <a:pPr lvl="3"/>
             <a:r>
-              <a:rPr lang="en-US" smtClean="0"/>
+              <a:rPr lang="en-US"/>
               <a:t>Fourth level</a:t>
             </a:r>
           </a:p>
           <a:p>
             <a:pPr lvl="4"/>
             <a:r>
-              <a:rPr lang="en-US" smtClean="0"/>
+              <a:rPr lang="en-US"/>
               <a:t>Fifth level</a:t>
             </a:r>
-            <a:endParaRPr lang="en-US"/>
           </a:p>
         </p:txBody>
       </p:sp>
@@ -1294,38 +1299,37 @@
           <a:p>
             <a:pPr lvl="0"/>
             <a:r>
-              <a:rPr lang="en-US" smtClean="0"/>
+              <a:rPr lang="en-US"/>
               <a:t>Click to edit Master text styles</a:t>
             </a:r>
           </a:p>
           <a:p>
             <a:pPr lvl="1"/>
             <a:r>
-              <a:rPr lang="en-US" smtClean="0"/>
+              <a:rPr lang="en-US"/>
               <a:t>Second level</a:t>
             </a:r>
           </a:p>
           <a:p>
             <a:pPr lvl="2"/>
             <a:r>
-              <a:rPr lang="en-US" smtClean="0"/>
+              <a:rPr lang="en-US"/>
               <a:t>Third level</a:t>
             </a:r>
           </a:p>
           <a:p>
             <a:pPr lvl="3"/>
             <a:r>
-              <a:rPr lang="en-US" smtClean="0"/>
+              <a:rPr lang="en-US"/>
               <a:t>Fourth level</a:t>
             </a:r>
           </a:p>
           <a:p>
             <a:pPr lvl="4"/>
             <a:r>
-              <a:rPr lang="en-US" smtClean="0"/>
+              <a:rPr lang="en-US"/>
               <a:t>Fifth level</a:t>
             </a:r>
-            <a:endParaRPr lang="en-US"/>
           </a:p>
         </p:txBody>
       </p:sp>
@@ -1346,7 +1350,7 @@
           <a:p>
             <a:fld id="{5BCAD085-E8A6-8845-BD4E-CB4CCA059FC4}" type="datetimeFigureOut">
               <a:rPr lang="en-US" smtClean="0"/>
-              <a:t>1/27/13</a:t>
+              <a:t>4/6/2026</a:t>
             </a:fld>
             <a:endParaRPr lang="en-US"/>
           </a:p>
@@ -1444,10 +1448,9 @@
           </a:lstStyle>
           <a:p>
             <a:r>
-              <a:rPr lang="en-US" smtClean="0"/>
+              <a:rPr lang="en-US"/>
               <a:t>Click to edit Master title style</a:t>
             </a:r>
-            <a:endParaRPr lang="en-US"/>
           </a:p>
         </p:txBody>
       </p:sp>
@@ -1510,7 +1513,7 @@
           <a:p>
             <a:pPr lvl="0"/>
             <a:r>
-              <a:rPr lang="en-US" smtClean="0"/>
+              <a:rPr lang="en-US"/>
               <a:t>Click to edit Master text styles</a:t>
             </a:r>
           </a:p>
@@ -1566,38 +1569,37 @@
           <a:p>
             <a:pPr lvl="0"/>
             <a:r>
-              <a:rPr lang="en-US" smtClean="0"/>
+              <a:rPr lang="en-US"/>
               <a:t>Click to edit Master text styles</a:t>
             </a:r>
           </a:p>
           <a:p>
             <a:pPr lvl="1"/>
             <a:r>
-              <a:rPr lang="en-US" smtClean="0"/>
+              <a:rPr lang="en-US"/>
               <a:t>Second level</a:t>
             </a:r>
           </a:p>
           <a:p>
             <a:pPr lvl="2"/>
             <a:r>
-              <a:rPr lang="en-US" smtClean="0"/>
+              <a:rPr lang="en-US"/>
               <a:t>Third level</a:t>
             </a:r>
           </a:p>
           <a:p>
             <a:pPr lvl="3"/>
             <a:r>
-              <a:rPr lang="en-US" smtClean="0"/>
+              <a:rPr lang="en-US"/>
               <a:t>Fourth level</a:t>
             </a:r>
           </a:p>
           <a:p>
             <a:pPr lvl="4"/>
             <a:r>
-              <a:rPr lang="en-US" smtClean="0"/>
+              <a:rPr lang="en-US"/>
               <a:t>Fifth level</a:t>
             </a:r>
-            <a:endParaRPr lang="en-US"/>
           </a:p>
         </p:txBody>
       </p:sp>
@@ -1660,7 +1662,7 @@
           <a:p>
             <a:pPr lvl="0"/>
             <a:r>
-              <a:rPr lang="en-US" smtClean="0"/>
+              <a:rPr lang="en-US"/>
               <a:t>Click to edit Master text styles</a:t>
             </a:r>
           </a:p>
@@ -1716,38 +1718,37 @@
           <a:p>
             <a:pPr lvl="0"/>
             <a:r>
-              <a:rPr lang="en-US" smtClean="0"/>
+              <a:rPr lang="en-US"/>
               <a:t>Click to edit Master text styles</a:t>
             </a:r>
           </a:p>
           <a:p>
             <a:pPr lvl="1"/>
             <a:r>
-              <a:rPr lang="en-US" smtClean="0"/>
+              <a:rPr lang="en-US"/>
               <a:t>Second level</a:t>
             </a:r>
           </a:p>
           <a:p>
             <a:pPr lvl="2"/>
             <a:r>
-              <a:rPr lang="en-US" smtClean="0"/>
+              <a:rPr lang="en-US"/>
               <a:t>Third level</a:t>
             </a:r>
           </a:p>
           <a:p>
             <a:pPr lvl="3"/>
             <a:r>
-              <a:rPr lang="en-US" smtClean="0"/>
+              <a:rPr lang="en-US"/>
               <a:t>Fourth level</a:t>
             </a:r>
           </a:p>
           <a:p>
             <a:pPr lvl="4"/>
             <a:r>
-              <a:rPr lang="en-US" smtClean="0"/>
+              <a:rPr lang="en-US"/>
               <a:t>Fifth level</a:t>
             </a:r>
-            <a:endParaRPr lang="en-US"/>
           </a:p>
         </p:txBody>
       </p:sp>
@@ -1768,7 +1769,7 @@
           <a:p>
             <a:fld id="{5BCAD085-E8A6-8845-BD4E-CB4CCA059FC4}" type="datetimeFigureOut">
               <a:rPr lang="en-US" smtClean="0"/>
-              <a:t>1/27/13</a:t>
+              <a:t>4/6/2026</a:t>
             </a:fld>
             <a:endParaRPr lang="en-US"/>
           </a:p>
@@ -1862,10 +1863,9 @@
           <a:lstStyle/>
           <a:p>
             <a:r>
-              <a:rPr lang="en-US" smtClean="0"/>
+              <a:rPr lang="en-US"/>
               <a:t>Click to edit Master title style</a:t>
             </a:r>
-            <a:endParaRPr lang="en-US"/>
           </a:p>
         </p:txBody>
       </p:sp>
@@ -1886,7 +1886,7 @@
           <a:p>
             <a:fld id="{5BCAD085-E8A6-8845-BD4E-CB4CCA059FC4}" type="datetimeFigureOut">
               <a:rPr lang="en-US" smtClean="0"/>
-              <a:t>1/27/13</a:t>
+              <a:t>4/6/2026</a:t>
             </a:fld>
             <a:endParaRPr lang="en-US"/>
           </a:p>
@@ -1981,7 +1981,7 @@
           <a:p>
             <a:fld id="{5BCAD085-E8A6-8845-BD4E-CB4CCA059FC4}" type="datetimeFigureOut">
               <a:rPr lang="en-US" smtClean="0"/>
-              <a:t>1/27/13</a:t>
+              <a:t>4/6/2026</a:t>
             </a:fld>
             <a:endParaRPr lang="en-US"/>
           </a:p>
@@ -2084,10 +2084,9 @@
           </a:lstStyle>
           <a:p>
             <a:r>
-              <a:rPr lang="en-US" smtClean="0"/>
+              <a:rPr lang="en-US"/>
               <a:t>Click to edit Master title style</a:t>
             </a:r>
-            <a:endParaRPr lang="en-US"/>
           </a:p>
         </p:txBody>
       </p:sp>
@@ -2141,38 +2140,37 @@
           <a:p>
             <a:pPr lvl="0"/>
             <a:r>
-              <a:rPr lang="en-US" smtClean="0"/>
+              <a:rPr lang="en-US"/>
               <a:t>Click to edit Master text styles</a:t>
             </a:r>
           </a:p>
           <a:p>
             <a:pPr lvl="1"/>
             <a:r>
-              <a:rPr lang="en-US" smtClean="0"/>
+              <a:rPr lang="en-US"/>
               <a:t>Second level</a:t>
             </a:r>
           </a:p>
           <a:p>
             <a:pPr lvl="2"/>
             <a:r>
-              <a:rPr lang="en-US" smtClean="0"/>
+              <a:rPr lang="en-US"/>
               <a:t>Third level</a:t>
             </a:r>
           </a:p>
           <a:p>
             <a:pPr lvl="3"/>
             <a:r>
-              <a:rPr lang="en-US" smtClean="0"/>
+              <a:rPr lang="en-US"/>
               <a:t>Fourth level</a:t>
             </a:r>
           </a:p>
           <a:p>
             <a:pPr lvl="4"/>
             <a:r>
-              <a:rPr lang="en-US" smtClean="0"/>
+              <a:rPr lang="en-US"/>
               <a:t>Fifth level</a:t>
             </a:r>
-            <a:endParaRPr lang="en-US"/>
           </a:p>
         </p:txBody>
       </p:sp>
@@ -2235,7 +2233,7 @@
           <a:p>
             <a:pPr lvl="0"/>
             <a:r>
-              <a:rPr lang="en-US" smtClean="0"/>
+              <a:rPr lang="en-US"/>
               <a:t>Click to edit Master text styles</a:t>
             </a:r>
           </a:p>
@@ -2258,7 +2256,7 @@
           <a:p>
             <a:fld id="{5BCAD085-E8A6-8845-BD4E-CB4CCA059FC4}" type="datetimeFigureOut">
               <a:rPr lang="en-US" smtClean="0"/>
-              <a:t>1/27/13</a:t>
+              <a:t>4/6/2026</a:t>
             </a:fld>
             <a:endParaRPr lang="en-US"/>
           </a:p>
@@ -2361,10 +2359,9 @@
           </a:lstStyle>
           <a:p>
             <a:r>
-              <a:rPr lang="en-US" smtClean="0"/>
+              <a:rPr lang="en-US"/>
               <a:t>Click to edit Master title style</a:t>
             </a:r>
-            <a:endParaRPr lang="en-US"/>
           </a:p>
         </p:txBody>
       </p:sp>
@@ -2488,7 +2485,7 @@
           <a:p>
             <a:pPr lvl="0"/>
             <a:r>
-              <a:rPr lang="en-US" smtClean="0"/>
+              <a:rPr lang="en-US"/>
               <a:t>Click to edit Master text styles</a:t>
             </a:r>
           </a:p>
@@ -2511,7 +2508,7 @@
           <a:p>
             <a:fld id="{5BCAD085-E8A6-8845-BD4E-CB4CCA059FC4}" type="datetimeFigureOut">
               <a:rPr lang="en-US" smtClean="0"/>
-              <a:t>1/27/13</a:t>
+              <a:t>4/6/2026</a:t>
             </a:fld>
             <a:endParaRPr lang="en-US"/>
           </a:p>
@@ -2620,10 +2617,9 @@
           <a:lstStyle/>
           <a:p>
             <a:r>
-              <a:rPr lang="en-US" smtClean="0"/>
+              <a:rPr lang="en-US"/>
               <a:t>Click to edit Master title style</a:t>
             </a:r>
-            <a:endParaRPr lang="en-US"/>
           </a:p>
         </p:txBody>
       </p:sp>
@@ -2654,38 +2650,37 @@
           <a:p>
             <a:pPr lvl="0"/>
             <a:r>
-              <a:rPr lang="en-US" smtClean="0"/>
+              <a:rPr lang="en-US"/>
               <a:t>Click to edit Master text styles</a:t>
             </a:r>
           </a:p>
           <a:p>
             <a:pPr lvl="1"/>
             <a:r>
-              <a:rPr lang="en-US" smtClean="0"/>
+              <a:rPr lang="en-US"/>
               <a:t>Second level</a:t>
             </a:r>
           </a:p>
           <a:p>
             <a:pPr lvl="2"/>
             <a:r>
-              <a:rPr lang="en-US" smtClean="0"/>
+              <a:rPr lang="en-US"/>
               <a:t>Third level</a:t>
             </a:r>
           </a:p>
           <a:p>
             <a:pPr lvl="3"/>
             <a:r>
-              <a:rPr lang="en-US" smtClean="0"/>
+              <a:rPr lang="en-US"/>
               <a:t>Fourth level</a:t>
             </a:r>
           </a:p>
           <a:p>
             <a:pPr lvl="4"/>
             <a:r>
-              <a:rPr lang="en-US" smtClean="0"/>
+              <a:rPr lang="en-US"/>
               <a:t>Fifth level</a:t>
             </a:r>
-            <a:endParaRPr lang="en-US"/>
           </a:p>
         </p:txBody>
       </p:sp>
@@ -2724,7 +2719,7 @@
           <a:p>
             <a:fld id="{5BCAD085-E8A6-8845-BD4E-CB4CCA059FC4}" type="datetimeFigureOut">
               <a:rPr lang="en-US" smtClean="0"/>
-              <a:t>1/27/13</a:t>
+              <a:t>4/6/2026</a:t>
             </a:fld>
             <a:endParaRPr lang="en-US"/>
           </a:p>
@@ -3083,7 +3078,7 @@
 </file>
 
 <file path=ppt/slides/slide1.xml><?xml version="1.0" encoding="utf-8"?>
-<p:sld xmlns:a="http://schemas.openxmlformats.org/drawingml/2006/main" xmlns:p="http://schemas.openxmlformats.org/presentationml/2006/main" xmlns:r="http://schemas.openxmlformats.org/officeDocument/2006/relationships">
+<p:sld xmlns:a="http://schemas.openxmlformats.org/drawingml/2006/main" xmlns:r="http://schemas.openxmlformats.org/officeDocument/2006/relationships" xmlns:p="http://schemas.openxmlformats.org/presentationml/2006/main">
   <p:cSld>
     <p:bg>
       <p:bgPr>
@@ -3099,7 +3094,14 @@
         <p:cNvGrpSpPr/>
         <p:nvPr/>
       </p:nvGrpSpPr>
-      <p:grpSpPr/>
+      <p:grpSpPr>
+        <a:xfrm>
+          <a:off x="0" y="0"/>
+          <a:ext cx="0" cy="0"/>
+          <a:chOff x="0" y="0"/>
+          <a:chExt cx="0" cy="0"/>
+        </a:xfrm>
+      </p:grpSpPr>
       <p:sp>
         <p:nvSpPr>
           <p:cNvPr id="2" name="Title 1"/>
@@ -3161,7 +3163,7 @@
 </file>
 
 <file path=ppt/slides/slide2.xml><?xml version="1.0" encoding="utf-8"?>
-<p:sld xmlns:a="http://schemas.openxmlformats.org/drawingml/2006/main" xmlns:p="http://schemas.openxmlformats.org/presentationml/2006/main" xmlns:r="http://schemas.openxmlformats.org/officeDocument/2006/relationships">
+<p:sld xmlns:a="http://schemas.openxmlformats.org/drawingml/2006/main" xmlns:r="http://schemas.openxmlformats.org/officeDocument/2006/relationships" xmlns:p="http://schemas.openxmlformats.org/presentationml/2006/main">
   <p:cSld>
     <p:bg>
       <p:bgPr>
@@ -3177,7 +3179,14 @@
         <p:cNvGrpSpPr/>
         <p:nvPr/>
       </p:nvGrpSpPr>
-      <p:grpSpPr/>
+      <p:grpSpPr>
+        <a:xfrm>
+          <a:off x="0" y="0"/>
+          <a:ext cx="0" cy="0"/>
+          <a:chOff x="0" y="0"/>
+          <a:chExt cx="0" cy="0"/>
+        </a:xfrm>
+      </p:grpSpPr>
       <p:sp>
         <p:nvSpPr>
           <p:cNvPr id="2" name="Title 1"/>
@@ -3199,7 +3208,7 @@
           <a:lstStyle/>
           <a:p>
             <a:r>
-              <a:rPr b="1" sz="3000">
+              <a:rPr sz="3000" b="1">
                 <a:solidFill>
                   <a:srgbClr val="E53935"/>
                 </a:solidFill>
@@ -3231,7 +3240,6 @@
           </a:bodyPr>
           <a:lstStyle/>
           <a:p>
-            <a:pPr/>
             <a:r>
               <a:rPr sz="1800">
                 <a:solidFill>
@@ -3242,7 +3250,6 @@
             </a:r>
           </a:p>
           <a:p>
-            <a:pPr/>
             <a:r>
               <a:rPr sz="1800">
                 <a:solidFill>
@@ -3253,7 +3260,6 @@
             </a:r>
           </a:p>
           <a:p>
-            <a:pPr/>
             <a:r>
               <a:rPr sz="1800">
                 <a:solidFill>
@@ -3264,7 +3270,6 @@
             </a:r>
           </a:p>
           <a:p>
-            <a:pPr/>
             <a:r>
               <a:rPr sz="1800">
                 <a:solidFill>
@@ -3275,7 +3280,6 @@
             </a:r>
           </a:p>
           <a:p>
-            <a:pPr/>
             <a:r>
               <a:rPr sz="1800">
                 <a:solidFill>
@@ -3327,6 +3331,7 @@
           <a:lstStyle/>
           <a:p>
             <a:pPr algn="ctr"/>
+            <a:endParaRPr/>
           </a:p>
         </p:txBody>
       </p:sp>
@@ -3339,7 +3344,7 @@
 </file>
 
 <file path=ppt/slides/slide3.xml><?xml version="1.0" encoding="utf-8"?>
-<p:sld xmlns:a="http://schemas.openxmlformats.org/drawingml/2006/main" xmlns:p="http://schemas.openxmlformats.org/presentationml/2006/main" xmlns:r="http://schemas.openxmlformats.org/officeDocument/2006/relationships">
+<p:sld xmlns:a="http://schemas.openxmlformats.org/drawingml/2006/main" xmlns:r="http://schemas.openxmlformats.org/officeDocument/2006/relationships" xmlns:p="http://schemas.openxmlformats.org/presentationml/2006/main">
   <p:cSld>
     <p:bg>
       <p:bgPr>
@@ -3355,7 +3360,14 @@
         <p:cNvGrpSpPr/>
         <p:nvPr/>
       </p:nvGrpSpPr>
-      <p:grpSpPr/>
+      <p:grpSpPr>
+        <a:xfrm>
+          <a:off x="0" y="0"/>
+          <a:ext cx="0" cy="0"/>
+          <a:chOff x="0" y="0"/>
+          <a:chExt cx="0" cy="0"/>
+        </a:xfrm>
+      </p:grpSpPr>
       <p:sp>
         <p:nvSpPr>
           <p:cNvPr id="2" name="Title 1"/>
@@ -3377,7 +3389,7 @@
           <a:lstStyle/>
           <a:p>
             <a:r>
-              <a:rPr b="1" sz="3000">
+              <a:rPr sz="3000" b="1">
                 <a:solidFill>
                   <a:srgbClr val="43A047"/>
                 </a:solidFill>
@@ -3409,7 +3421,6 @@
           </a:bodyPr>
           <a:lstStyle/>
           <a:p>
-            <a:pPr/>
             <a:r>
               <a:rPr sz="1800">
                 <a:solidFill>
@@ -3420,7 +3431,6 @@
             </a:r>
           </a:p>
           <a:p>
-            <a:pPr/>
             <a:r>
               <a:rPr sz="1800">
                 <a:solidFill>
@@ -3431,7 +3441,6 @@
             </a:r>
           </a:p>
           <a:p>
-            <a:pPr/>
             <a:r>
               <a:rPr sz="1800">
                 <a:solidFill>
@@ -3442,7 +3451,6 @@
             </a:r>
           </a:p>
           <a:p>
-            <a:pPr/>
             <a:r>
               <a:rPr sz="1800">
                 <a:solidFill>
@@ -3453,7 +3461,6 @@
             </a:r>
           </a:p>
           <a:p>
-            <a:pPr/>
             <a:r>
               <a:rPr sz="1800">
                 <a:solidFill>
@@ -3505,6 +3512,7 @@
           <a:lstStyle/>
           <a:p>
             <a:pPr algn="ctr"/>
+            <a:endParaRPr/>
           </a:p>
         </p:txBody>
       </p:sp>
@@ -3517,7 +3525,7 @@
 </file>
 
 <file path=ppt/slides/slide4.xml><?xml version="1.0" encoding="utf-8"?>
-<p:sld xmlns:a="http://schemas.openxmlformats.org/drawingml/2006/main" xmlns:p="http://schemas.openxmlformats.org/presentationml/2006/main" xmlns:r="http://schemas.openxmlformats.org/officeDocument/2006/relationships">
+<p:sld xmlns:a="http://schemas.openxmlformats.org/drawingml/2006/main" xmlns:r="http://schemas.openxmlformats.org/officeDocument/2006/relationships" xmlns:p="http://schemas.openxmlformats.org/presentationml/2006/main">
   <p:cSld>
     <p:bg>
       <p:bgPr>
@@ -3533,7 +3541,14 @@
         <p:cNvGrpSpPr/>
         <p:nvPr/>
       </p:nvGrpSpPr>
-      <p:grpSpPr/>
+      <p:grpSpPr>
+        <a:xfrm>
+          <a:off x="0" y="0"/>
+          <a:ext cx="0" cy="0"/>
+          <a:chOff x="0" y="0"/>
+          <a:chExt cx="0" cy="0"/>
+        </a:xfrm>
+      </p:grpSpPr>
       <p:sp>
         <p:nvSpPr>
           <p:cNvPr id="2" name="Title 1"/>
@@ -3555,12 +3570,12 @@
           <a:lstStyle/>
           <a:p>
             <a:r>
-              <a:rPr b="1" sz="3000">
-                <a:solidFill>
-                  <a:srgbClr val="8E24AA"/>
+              <a:rPr sz="3000" b="1">
+                <a:solidFill>
+                  <a:srgbClr val="FB8C00"/>
                 </a:solidFill>
               </a:rPr>
-              <a:t>Uses &amp; Global Importance</a:t>
+              <a:t>Cultivation &amp; Major Varieties</a:t>
             </a:r>
           </a:p>
         </p:txBody>
@@ -3587,58 +3602,53 @@
           </a:bodyPr>
           <a:lstStyle/>
           <a:p>
-            <a:pPr/>
             <a:r>
               <a:rPr sz="1800">
                 <a:solidFill>
-                  <a:srgbClr val="8E24AA"/>
+                  <a:srgbClr val="FB8C00"/>
                 </a:solidFill>
               </a:rPr>
-              <a:t>Used globally in sauces, salads, soups, juices, and pastes</a:t>
-            </a:r>
-          </a:p>
-          <a:p>
-            <a:pPr/>
+              <a:t>Grows best in warm climates with temperatures 20–27°C</a:t>
+            </a:r>
+          </a:p>
+          <a:p>
             <a:r>
               <a:rPr sz="1800">
                 <a:solidFill>
-                  <a:srgbClr val="8E24AA"/>
+                  <a:srgbClr val="FB8C00"/>
                 </a:solidFill>
               </a:rPr>
-              <a:t>Ketchup, tomato puree, and canned tomatoes are major processed products</a:t>
-            </a:r>
-          </a:p>
-          <a:p>
-            <a:pPr/>
+              <a:t>Requires well-drained, slightly acidic soil (pH 6.0–6.8)</a:t>
+            </a:r>
+          </a:p>
+          <a:p>
             <a:r>
               <a:rPr sz="1800">
                 <a:solidFill>
-                  <a:srgbClr val="8E24AA"/>
+                  <a:srgbClr val="FB8C00"/>
                 </a:solidFill>
               </a:rPr>
-              <a:t>Global tomato market valued at over $200 billion USD</a:t>
-            </a:r>
-          </a:p>
-          <a:p>
-            <a:pPr/>
+              <a:t>Common varieties: Cherry, Roma, Beefsteak, Heirloom, Grape</a:t>
+            </a:r>
+          </a:p>
+          <a:p>
             <a:r>
               <a:rPr sz="1800">
                 <a:solidFill>
-                  <a:srgbClr val="8E24AA"/>
+                  <a:srgbClr val="FB8C00"/>
                 </a:solidFill>
               </a:rPr>
-              <a:t>Key export countries: USA, Mexico, Netherlands, Spain, India</a:t>
-            </a:r>
-          </a:p>
-          <a:p>
-            <a:pPr/>
+              <a:t>China is the world’s largest tomato producer (&gt;60 million tonnes/year)</a:t>
+            </a:r>
+          </a:p>
+          <a:p>
             <a:r>
               <a:rPr sz="1800">
                 <a:solidFill>
-                  <a:srgbClr val="8E24AA"/>
+                  <a:srgbClr val="FB8C00"/>
                 </a:solidFill>
               </a:rPr>
-              <a:t>Integral ingredient in cuisines: Italian, Indian, Mexican, and more</a:t>
+              <a:t>Grown in greenhouses, open fields, and even home gardens</a:t>
             </a:r>
           </a:p>
         </p:txBody>
@@ -3683,6 +3693,7 @@
           <a:lstStyle/>
           <a:p>
             <a:pPr algn="ctr"/>
+            <a:endParaRPr/>
           </a:p>
         </p:txBody>
       </p:sp>
@@ -3694,8 +3705,8 @@
 </p:sld>
 </file>
 
-<file path=ppt/slides/slide4.xml><?xml version="1.0" encoding="utf-8"?>
-<p:sld xmlns:a="http://schemas.openxmlformats.org/drawingml/2006/main" xmlns:p="http://schemas.openxmlformats.org/presentationml/2006/main" xmlns:r="http://schemas.openxmlformats.org/officeDocument/2006/relationships">
+<file path=ppt/slides/slide5.xml><?xml version="1.0" encoding="utf-8"?>
+<p:sld xmlns:a="http://schemas.openxmlformats.org/drawingml/2006/main" xmlns:r="http://schemas.openxmlformats.org/officeDocument/2006/relationships" xmlns:p="http://schemas.openxmlformats.org/presentationml/2006/main">
   <p:cSld>
     <p:bg>
       <p:bgPr>
@@ -3711,7 +3722,14 @@
         <p:cNvGrpSpPr/>
         <p:nvPr/>
       </p:nvGrpSpPr>
-      <p:grpSpPr/>
+      <p:grpSpPr>
+        <a:xfrm>
+          <a:off x="0" y="0"/>
+          <a:ext cx="0" cy="0"/>
+          <a:chOff x="0" y="0"/>
+          <a:chExt cx="0" cy="0"/>
+        </a:xfrm>
+      </p:grpSpPr>
       <p:sp>
         <p:nvSpPr>
           <p:cNvPr id="2" name="Title 1"/>
@@ -3733,12 +3751,12 @@
           <a:lstStyle/>
           <a:p>
             <a:r>
-              <a:rPr b="1" sz="3000">
-                <a:solidFill>
-                  <a:srgbClr val="8E24AA"/>
+              <a:rPr sz="3000" b="1">
+                <a:solidFill>
+                  <a:srgbClr val="C62828"/>
                 </a:solidFill>
               </a:rPr>
-              <a:t>Uses &amp; Global Importance</a:t>
+              <a:t>Conclusion</a:t>
             </a:r>
           </a:p>
         </p:txBody>
@@ -3765,58 +3783,53 @@
           </a:bodyPr>
           <a:lstStyle/>
           <a:p>
-            <a:pPr/>
             <a:r>
               <a:rPr sz="1800">
                 <a:solidFill>
-                  <a:srgbClr val="8E24AA"/>
+                  <a:srgbClr val="C62828"/>
                 </a:solidFill>
               </a:rPr>
-              <a:t>Used globally in sauces, salads, soups, juices, and pastes</a:t>
-            </a:r>
-          </a:p>
-          <a:p>
-            <a:pPr/>
+              <a:t>Tomato is one of the most versatile and nutritionally rich fruits in the world</a:t>
+            </a:r>
+          </a:p>
+          <a:p>
             <a:r>
               <a:rPr sz="1800">
                 <a:solidFill>
-                  <a:srgbClr val="8E24AA"/>
+                  <a:srgbClr val="C62828"/>
                 </a:solidFill>
               </a:rPr>
-              <a:t>Ketchup, tomato puree, and canned tomatoes are major processed products</a:t>
-            </a:r>
-          </a:p>
-          <a:p>
-            <a:pPr/>
+              <a:t>From its South American origins, it has become a global culinary staple</a:t>
+            </a:r>
+          </a:p>
+          <a:p>
             <a:r>
               <a:rPr sz="1800">
                 <a:solidFill>
-                  <a:srgbClr val="8E24AA"/>
+                  <a:srgbClr val="C62828"/>
                 </a:solidFill>
               </a:rPr>
-              <a:t>Global tomato market valued at over $200 billion USD</a:t>
-            </a:r>
-          </a:p>
-          <a:p>
-            <a:pPr/>
+              <a:t>Rich in lycopene, vitamins, and antioxidants — a true superfood</a:t>
+            </a:r>
+          </a:p>
+          <a:p>
             <a:r>
               <a:rPr sz="1800">
                 <a:solidFill>
-                  <a:srgbClr val="8E24AA"/>
+                  <a:srgbClr val="C62828"/>
                 </a:solidFill>
               </a:rPr>
-              <a:t>Key export countries: USA, Mexico, Netherlands, Spain, India</a:t>
-            </a:r>
-          </a:p>
-          <a:p>
-            <a:pPr/>
+              <a:t>Plays a vital economic role with a global market worth over $200 billion</a:t>
+            </a:r>
+          </a:p>
+          <a:p>
             <a:r>
               <a:rPr sz="1800">
                 <a:solidFill>
-                  <a:srgbClr val="8E24AA"/>
+                  <a:srgbClr val="C62828"/>
                 </a:solidFill>
               </a:rPr>
-              <a:t>Integral ingredient in cuisines: Italian, Indian, Mexican, and more</a:t>
+              <a:t>Whether fresh, cooked, or processed — the tomato remains irreplaceable in our daily lives</a:t>
             </a:r>
           </a:p>
         </p:txBody>
@@ -3861,184 +3874,7 @@
           <a:lstStyle/>
           <a:p>
             <a:pPr algn="ctr"/>
-          </a:p>
-        </p:txBody>
-      </p:sp>
-    </p:spTree>
-  </p:cSld>
-  <p:clrMapOvr>
-    <a:masterClrMapping/>
-  </p:clrMapOvr>
-</p:sld>
-</file>
-
-<file path=ppt/slides/slide5.xml><?xml version="1.0" encoding="utf-8"?>
-<p:sld xmlns:a="http://schemas.openxmlformats.org/drawingml/2006/main" xmlns:p="http://schemas.openxmlformats.org/presentationml/2006/main" xmlns:r="http://schemas.openxmlformats.org/officeDocument/2006/relationships">
-  <p:cSld>
-    <p:bg>
-      <p:bgPr>
-        <a:solidFill>
-          <a:srgbClr val="0F192D"/>
-        </a:solidFill>
-        <a:effectLst/>
-      </p:bgPr>
-    </p:bg>
-    <p:spTree>
-      <p:nvGrpSpPr>
-        <p:cNvPr id="1" name=""/>
-        <p:cNvGrpSpPr/>
-        <p:nvPr/>
-      </p:nvGrpSpPr>
-      <p:grpSpPr/>
-      <p:sp>
-        <p:nvSpPr>
-          <p:cNvPr id="2" name="Title 1"/>
-          <p:cNvSpPr>
-            <a:spLocks noGrp="1"/>
-          </p:cNvSpPr>
-          <p:nvPr>
-            <p:ph type="title"/>
-          </p:nvPr>
-        </p:nvSpPr>
-        <p:spPr>
-          <a:xfrm>
-            <a:off x="457200" y="365760"/>
-            <a:ext cx="8229600" cy="0"/>
-          </a:xfrm>
-        </p:spPr>
-        <p:txBody>
-          <a:bodyPr/>
-          <a:lstStyle/>
-          <a:p>
-            <a:r>
-              <a:rPr b="1" sz="3000">
-                <a:solidFill>
-                  <a:srgbClr val="C62828"/>
-                </a:solidFill>
-              </a:rPr>
-              <a:t>Conclusion</a:t>
-            </a:r>
-          </a:p>
-        </p:txBody>
-      </p:sp>
-      <p:sp>
-        <p:nvSpPr>
-          <p:cNvPr id="3" name="Content Placeholder 2"/>
-          <p:cNvSpPr>
-            <a:spLocks noGrp="1"/>
-          </p:cNvSpPr>
-          <p:nvPr>
-            <p:ph idx="1"/>
-          </p:nvPr>
-        </p:nvSpPr>
-        <p:spPr>
-          <a:xfrm>
-            <a:off x="457200" y="1645920"/>
-            <a:ext cx="8686800" cy="4114800"/>
-          </a:xfrm>
-        </p:spPr>
-        <p:txBody>
-          <a:bodyPr wrap="square" lIns="45720" rIns="45720">
-            <a:noAutofit/>
-          </a:bodyPr>
-          <a:lstStyle/>
-          <a:p>
-            <a:pPr/>
-            <a:r>
-              <a:rPr sz="1800">
-                <a:solidFill>
-                  <a:srgbClr val="C62828"/>
-                </a:solidFill>
-              </a:rPr>
-              <a:t>Tomato is one of the most versatile and nutritionally rich fruits in the world</a:t>
-            </a:r>
-          </a:p>
-          <a:p>
-            <a:pPr/>
-            <a:r>
-              <a:rPr sz="1800">
-                <a:solidFill>
-                  <a:srgbClr val="C62828"/>
-                </a:solidFill>
-              </a:rPr>
-              <a:t>From its South American origins, it has become a global culinary staple</a:t>
-            </a:r>
-          </a:p>
-          <a:p>
-            <a:pPr/>
-            <a:r>
-              <a:rPr sz="1800">
-                <a:solidFill>
-                  <a:srgbClr val="C62828"/>
-                </a:solidFill>
-              </a:rPr>
-              <a:t>Rich in lycopene, vitamins, and antioxidants — a true superfood</a:t>
-            </a:r>
-          </a:p>
-          <a:p>
-            <a:pPr/>
-            <a:r>
-              <a:rPr sz="1800">
-                <a:solidFill>
-                  <a:srgbClr val="C62828"/>
-                </a:solidFill>
-              </a:rPr>
-              <a:t>Plays a vital economic role with a global market worth over $200 billion</a:t>
-            </a:r>
-          </a:p>
-          <a:p>
-            <a:pPr/>
-            <a:r>
-              <a:rPr sz="1800">
-                <a:solidFill>
-                  <a:srgbClr val="C62828"/>
-                </a:solidFill>
-              </a:rPr>
-              <a:t>Whether fresh, cooked, or processed — the tomato remains irreplaceable in our daily lives</a:t>
-            </a:r>
-          </a:p>
-        </p:txBody>
-      </p:sp>
-      <p:sp>
-        <p:nvSpPr>
-          <p:cNvPr id="4" name="Rectangle 3"/>
-          <p:cNvSpPr/>
-          <p:nvPr/>
-        </p:nvSpPr>
-        <p:spPr>
-          <a:xfrm>
-            <a:off x="0" y="6766560"/>
-            <a:ext cx="9144000" cy="91440"/>
-          </a:xfrm>
-          <a:prstGeom prst="rect">
-            <a:avLst/>
-          </a:prstGeom>
-          <a:solidFill>
-            <a:srgbClr val="0070C0"/>
-          </a:solidFill>
-          <a:ln>
-            <a:noFill/>
-          </a:ln>
-        </p:spPr>
-        <p:style>
-          <a:lnRef idx="1">
-            <a:schemeClr val="accent1"/>
-          </a:lnRef>
-          <a:fillRef idx="3">
-            <a:schemeClr val="accent1"/>
-          </a:fillRef>
-          <a:effectRef idx="2">
-            <a:schemeClr val="accent1"/>
-          </a:effectRef>
-          <a:fontRef idx="minor">
-            <a:schemeClr val="lt1"/>
-          </a:fontRef>
-        </p:style>
-        <p:txBody>
-          <a:bodyPr rtlCol="0" anchor="ctr"/>
-          <a:lstStyle/>
-          <a:p>
-            <a:pPr algn="ctr"/>
+            <a:endParaRPr/>
           </a:p>
         </p:txBody>
       </p:sp>

</xml_diff>